<commit_message>
Add verified app QR code to MVP title slide
</commit_message>
<xml_diff>
--- a/submission/PathwayAI_MVP_Title_Slide.pptx
+++ b/submission/PathwayAI_MVP_Title_Slide.pptx
@@ -4154,6 +4154,68 @@
                 </a:solidFill>
               </a:rPr>
               <a:t>pathwayai.streamlit.app</a:t>
+            </a:r>
+          </a:p>
+        </p:txBody>
+      </p:sp>
+      <p:pic>
+        <p:nvPicPr>
+          <p:cNvPr id="28" name="PathwayAI_App_QR" descr="PathwayAI_App_QR.png">
+            <a:hlinkClick r:id="rId4"/>
+          </p:cNvPr>
+          <p:cNvPicPr>
+            <a:picLocks noChangeAspect="1"/>
+          </p:cNvPicPr>
+          <p:nvPr/>
+        </p:nvPicPr>
+        <p:blipFill>
+          <a:blip r:embed="rId3"/>
+          <a:stretch>
+            <a:fillRect/>
+          </a:stretch>
+        </p:blipFill>
+        <p:spPr>
+          <a:xfrm>
+            <a:off x="6601968" y="1078992"/>
+            <a:ext cx="1874519" cy="1874519"/>
+          </a:xfrm>
+          <a:prstGeom prst="rect">
+            <a:avLst/>
+          </a:prstGeom>
+        </p:spPr>
+      </p:pic>
+      <p:sp>
+        <p:nvSpPr>
+          <p:cNvPr id="29" name="PathwayAI_QR_Caption"/>
+          <p:cNvSpPr txBox="1"/>
+          <p:nvPr/>
+        </p:nvSpPr>
+        <p:spPr>
+          <a:xfrm>
+            <a:off x="6601968" y="3017520"/>
+            <a:ext cx="1874519" cy="256032"/>
+          </a:xfrm>
+          <a:prstGeom prst="rect">
+            <a:avLst/>
+          </a:prstGeom>
+          <a:noFill/>
+        </p:spPr>
+        <p:txBody>
+          <a:bodyPr wrap="none" tIns="0">
+            <a:spAutoFit/>
+          </a:bodyPr>
+          <a:lstStyle/>
+          <a:p>
+            <a:pPr algn="ctr">
+              <a:defRPr sz="1100">
+                <a:solidFill>
+                  <a:srgbClr val="FFFFFF"/>
+                </a:solidFill>
+                <a:latin typeface="Arial"/>
+              </a:defRPr>
+            </a:pPr>
+            <a:r>
+              <a:t>Scan to try PathwayAI</a:t>
             </a:r>
           </a:p>
         </p:txBody>

</xml_diff>